<commit_message>
minor edits to methods and results sections, major edits to results section, changed figure 5 and 6.
</commit_message>
<xml_diff>
--- a/Figures3 - Copy for editing for the paper.pptx
+++ b/Figures3 - Copy for editing for the paper.pptx
@@ -206,7 +206,7 @@
           <a:p>
             <a:fld id="{9236FA1A-EBA2-4406-90A4-2C427B932B98}" type="datetimeFigureOut">
               <a:rPr lang="en-US" smtClean="0"/>
-              <a:t>4/23/2026</a:t>
+              <a:t>5/12/2026</a:t>
             </a:fld>
             <a:endParaRPr lang="en-US"/>
           </a:p>
@@ -889,7 +889,7 @@
           <a:p>
             <a:fld id="{65ED2174-11EF-43AA-A635-42A92FC4881C}" type="datetimeFigureOut">
               <a:rPr lang="en-US" smtClean="0"/>
-              <a:t>4/23/2026</a:t>
+              <a:t>5/12/2026</a:t>
             </a:fld>
             <a:endParaRPr lang="en-US"/>
           </a:p>
@@ -1059,7 +1059,7 @@
           <a:p>
             <a:fld id="{65ED2174-11EF-43AA-A635-42A92FC4881C}" type="datetimeFigureOut">
               <a:rPr lang="en-US" smtClean="0"/>
-              <a:t>4/23/2026</a:t>
+              <a:t>5/12/2026</a:t>
             </a:fld>
             <a:endParaRPr lang="en-US"/>
           </a:p>
@@ -1239,7 +1239,7 @@
           <a:p>
             <a:fld id="{65ED2174-11EF-43AA-A635-42A92FC4881C}" type="datetimeFigureOut">
               <a:rPr lang="en-US" smtClean="0"/>
-              <a:t>4/23/2026</a:t>
+              <a:t>5/12/2026</a:t>
             </a:fld>
             <a:endParaRPr lang="en-US"/>
           </a:p>
@@ -1409,7 +1409,7 @@
           <a:p>
             <a:fld id="{65ED2174-11EF-43AA-A635-42A92FC4881C}" type="datetimeFigureOut">
               <a:rPr lang="en-US" smtClean="0"/>
-              <a:t>4/23/2026</a:t>
+              <a:t>5/12/2026</a:t>
             </a:fld>
             <a:endParaRPr lang="en-US"/>
           </a:p>
@@ -1653,7 +1653,7 @@
           <a:p>
             <a:fld id="{65ED2174-11EF-43AA-A635-42A92FC4881C}" type="datetimeFigureOut">
               <a:rPr lang="en-US" smtClean="0"/>
-              <a:t>4/23/2026</a:t>
+              <a:t>5/12/2026</a:t>
             </a:fld>
             <a:endParaRPr lang="en-US"/>
           </a:p>
@@ -1885,7 +1885,7 @@
           <a:p>
             <a:fld id="{65ED2174-11EF-43AA-A635-42A92FC4881C}" type="datetimeFigureOut">
               <a:rPr lang="en-US" smtClean="0"/>
-              <a:t>4/23/2026</a:t>
+              <a:t>5/12/2026</a:t>
             </a:fld>
             <a:endParaRPr lang="en-US"/>
           </a:p>
@@ -2252,7 +2252,7 @@
           <a:p>
             <a:fld id="{65ED2174-11EF-43AA-A635-42A92FC4881C}" type="datetimeFigureOut">
               <a:rPr lang="en-US" smtClean="0"/>
-              <a:t>4/23/2026</a:t>
+              <a:t>5/12/2026</a:t>
             </a:fld>
             <a:endParaRPr lang="en-US"/>
           </a:p>
@@ -2370,7 +2370,7 @@
           <a:p>
             <a:fld id="{65ED2174-11EF-43AA-A635-42A92FC4881C}" type="datetimeFigureOut">
               <a:rPr lang="en-US" smtClean="0"/>
-              <a:t>4/23/2026</a:t>
+              <a:t>5/12/2026</a:t>
             </a:fld>
             <a:endParaRPr lang="en-US"/>
           </a:p>
@@ -2465,7 +2465,7 @@
           <a:p>
             <a:fld id="{65ED2174-11EF-43AA-A635-42A92FC4881C}" type="datetimeFigureOut">
               <a:rPr lang="en-US" smtClean="0"/>
-              <a:t>4/23/2026</a:t>
+              <a:t>5/12/2026</a:t>
             </a:fld>
             <a:endParaRPr lang="en-US"/>
           </a:p>
@@ -2742,7 +2742,7 @@
           <a:p>
             <a:fld id="{65ED2174-11EF-43AA-A635-42A92FC4881C}" type="datetimeFigureOut">
               <a:rPr lang="en-US" smtClean="0"/>
-              <a:t>4/23/2026</a:t>
+              <a:t>5/12/2026</a:t>
             </a:fld>
             <a:endParaRPr lang="en-US"/>
           </a:p>
@@ -2999,7 +2999,7 @@
           <a:p>
             <a:fld id="{65ED2174-11EF-43AA-A635-42A92FC4881C}" type="datetimeFigureOut">
               <a:rPr lang="en-US" smtClean="0"/>
-              <a:t>4/23/2026</a:t>
+              <a:t>5/12/2026</a:t>
             </a:fld>
             <a:endParaRPr lang="en-US"/>
           </a:p>
@@ -3212,7 +3212,7 @@
           <a:p>
             <a:fld id="{65ED2174-11EF-43AA-A635-42A92FC4881C}" type="datetimeFigureOut">
               <a:rPr lang="en-US" smtClean="0"/>
-              <a:t>4/23/2026</a:t>
+              <a:t>5/12/2026</a:t>
             </a:fld>
             <a:endParaRPr lang="en-US"/>
           </a:p>
@@ -10047,7 +10047,7 @@
         </p:blipFill>
         <p:spPr>
           <a:xfrm>
-            <a:off x="6588376" y="8989412"/>
+            <a:off x="6934746" y="7042759"/>
             <a:ext cx="5575503" cy="4186001"/>
           </a:xfrm>
           <a:prstGeom prst="rect">
@@ -10077,7 +10077,7 @@
         </p:blipFill>
         <p:spPr>
           <a:xfrm>
-            <a:off x="8896616" y="4803412"/>
+            <a:off x="2318270" y="7042759"/>
             <a:ext cx="5575503" cy="4186001"/>
           </a:xfrm>
           <a:prstGeom prst="rect">
@@ -10107,7 +10107,7 @@
         </p:blipFill>
         <p:spPr>
           <a:xfrm>
-            <a:off x="4280140" y="4803412"/>
+            <a:off x="11551225" y="2856757"/>
             <a:ext cx="5575503" cy="4186001"/>
           </a:xfrm>
           <a:prstGeom prst="rect">
@@ -10137,7 +10137,7 @@
         </p:blipFill>
         <p:spPr>
           <a:xfrm>
-            <a:off x="8896616" y="617410"/>
+            <a:off x="6934746" y="2856759"/>
             <a:ext cx="5575503" cy="4186001"/>
           </a:xfrm>
           <a:prstGeom prst="rect">
@@ -10167,7 +10167,7 @@
         </p:blipFill>
         <p:spPr>
           <a:xfrm>
-            <a:off x="4280140" y="617410"/>
+            <a:off x="2318270" y="2856759"/>
             <a:ext cx="5575503" cy="4186001"/>
           </a:xfrm>
           <a:prstGeom prst="rect">
@@ -10189,7 +10189,7 @@
         </p:nvSpPr>
         <p:spPr>
           <a:xfrm>
-            <a:off x="8219835" y="3725617"/>
+            <a:off x="6257965" y="5964966"/>
             <a:ext cx="628651" cy="461665"/>
           </a:xfrm>
           <a:prstGeom prst="rect">
@@ -10232,7 +10232,7 @@
         </p:nvSpPr>
         <p:spPr>
           <a:xfrm>
-            <a:off x="12839722" y="3725615"/>
+            <a:off x="10877852" y="5964964"/>
             <a:ext cx="628651" cy="461665"/>
           </a:xfrm>
           <a:prstGeom prst="rect">
@@ -10275,7 +10275,7 @@
         </p:nvSpPr>
         <p:spPr>
           <a:xfrm>
-            <a:off x="8219835" y="7911615"/>
+            <a:off x="15490920" y="5964960"/>
             <a:ext cx="628651" cy="461665"/>
           </a:xfrm>
           <a:prstGeom prst="rect">
@@ -10318,7 +10318,7 @@
         </p:nvSpPr>
         <p:spPr>
           <a:xfrm>
-            <a:off x="12839722" y="7911615"/>
+            <a:off x="6261376" y="10150962"/>
             <a:ext cx="628651" cy="461665"/>
           </a:xfrm>
           <a:prstGeom prst="rect">
@@ -10361,7 +10361,7 @@
         </p:nvSpPr>
         <p:spPr>
           <a:xfrm>
-            <a:off x="10537679" y="12106626"/>
+            <a:off x="10884049" y="10159973"/>
             <a:ext cx="628651" cy="461665"/>
           </a:xfrm>
           <a:prstGeom prst="rect">
@@ -10436,7 +10436,7 @@
         </p:blipFill>
         <p:spPr>
           <a:xfrm>
-            <a:off x="6023060" y="8933425"/>
+            <a:off x="6595806" y="6147016"/>
             <a:ext cx="5575503" cy="4186001"/>
           </a:xfrm>
           <a:prstGeom prst="rect">
@@ -10460,7 +10460,7 @@
         </p:blipFill>
         <p:spPr>
           <a:xfrm>
-            <a:off x="8331299" y="4747425"/>
+            <a:off x="1979330" y="6147016"/>
             <a:ext cx="5575503" cy="4186001"/>
           </a:xfrm>
           <a:prstGeom prst="rect">
@@ -10484,7 +10484,7 @@
         </p:blipFill>
         <p:spPr>
           <a:xfrm>
-            <a:off x="3714823" y="4747425"/>
+            <a:off x="11212282" y="1961015"/>
             <a:ext cx="5575503" cy="4186001"/>
           </a:xfrm>
           <a:prstGeom prst="rect">
@@ -10508,7 +10508,7 @@
         </p:blipFill>
         <p:spPr>
           <a:xfrm>
-            <a:off x="8331300" y="561423"/>
+            <a:off x="6595806" y="1961015"/>
             <a:ext cx="5575503" cy="4186001"/>
           </a:xfrm>
           <a:prstGeom prst="rect">
@@ -10532,7 +10532,7 @@
         </p:blipFill>
         <p:spPr>
           <a:xfrm>
-            <a:off x="3714824" y="561423"/>
+            <a:off x="1979330" y="1961015"/>
             <a:ext cx="5575503" cy="4186001"/>
           </a:xfrm>
           <a:prstGeom prst="rect">
@@ -10554,7 +10554,7 @@
         </p:nvSpPr>
         <p:spPr>
           <a:xfrm>
-            <a:off x="7646090" y="3669630"/>
+            <a:off x="5910596" y="5069222"/>
             <a:ext cx="628651" cy="461665"/>
           </a:xfrm>
           <a:prstGeom prst="rect">
@@ -10597,7 +10597,7 @@
         </p:nvSpPr>
         <p:spPr>
           <a:xfrm>
-            <a:off x="12265975" y="3669628"/>
+            <a:off x="10530481" y="5069220"/>
             <a:ext cx="628651" cy="461665"/>
           </a:xfrm>
           <a:prstGeom prst="rect">
@@ -10640,7 +10640,7 @@
         </p:nvSpPr>
         <p:spPr>
           <a:xfrm>
-            <a:off x="7646090" y="7855628"/>
+            <a:off x="15143549" y="5069218"/>
             <a:ext cx="628651" cy="461665"/>
           </a:xfrm>
           <a:prstGeom prst="rect">
@@ -10683,7 +10683,7 @@
         </p:nvSpPr>
         <p:spPr>
           <a:xfrm>
-            <a:off x="12265975" y="7855628"/>
+            <a:off x="5914006" y="9255219"/>
             <a:ext cx="628651" cy="461665"/>
           </a:xfrm>
           <a:prstGeom prst="rect">
@@ -10726,7 +10726,7 @@
         </p:nvSpPr>
         <p:spPr>
           <a:xfrm>
-            <a:off x="9963934" y="12050639"/>
+            <a:off x="10536680" y="9264230"/>
             <a:ext cx="628651" cy="461665"/>
           </a:xfrm>
           <a:prstGeom prst="rect">

</xml_diff>

<commit_message>
minor changes to experimental protocol, and added a statistical analysis section in methods and materials section. minor rewrite of section 3.2, major rewrites of section 3.3, and redesigned table 2 in results.
</commit_message>
<xml_diff>
--- a/Figures3 - Copy for editing for the paper.pptx
+++ b/Figures3 - Copy for editing for the paper.pptx
@@ -5,7 +5,7 @@
     <p:sldMasterId id="2147483684" r:id="rId1"/>
   </p:sldMasterIdLst>
   <p:notesMasterIdLst>
-    <p:notesMasterId r:id="rId12"/>
+    <p:notesMasterId r:id="rId13"/>
   </p:notesMasterIdLst>
   <p:sldIdLst>
     <p:sldId id="274" r:id="rId2"/>
@@ -16,8 +16,9 @@
     <p:sldId id="265" r:id="rId7"/>
     <p:sldId id="266" r:id="rId8"/>
     <p:sldId id="261" r:id="rId9"/>
-    <p:sldId id="277" r:id="rId10"/>
-    <p:sldId id="262" r:id="rId11"/>
+    <p:sldId id="279" r:id="rId10"/>
+    <p:sldId id="277" r:id="rId11"/>
+    <p:sldId id="262" r:id="rId12"/>
   </p:sldIdLst>
   <p:sldSz cx="18288000" cy="13716000"/>
   <p:notesSz cx="6858000" cy="9144000"/>
@@ -206,7 +207,7 @@
           <a:p>
             <a:fld id="{9236FA1A-EBA2-4406-90A4-2C427B932B98}" type="datetimeFigureOut">
               <a:rPr lang="en-US" smtClean="0"/>
-              <a:t>5/12/2026</a:t>
+              <a:t>5/15/2026</a:t>
             </a:fld>
             <a:endParaRPr lang="en-US"/>
           </a:p>
@@ -889,7 +890,7 @@
           <a:p>
             <a:fld id="{65ED2174-11EF-43AA-A635-42A92FC4881C}" type="datetimeFigureOut">
               <a:rPr lang="en-US" smtClean="0"/>
-              <a:t>5/12/2026</a:t>
+              <a:t>5/15/2026</a:t>
             </a:fld>
             <a:endParaRPr lang="en-US"/>
           </a:p>
@@ -1059,7 +1060,7 @@
           <a:p>
             <a:fld id="{65ED2174-11EF-43AA-A635-42A92FC4881C}" type="datetimeFigureOut">
               <a:rPr lang="en-US" smtClean="0"/>
-              <a:t>5/12/2026</a:t>
+              <a:t>5/15/2026</a:t>
             </a:fld>
             <a:endParaRPr lang="en-US"/>
           </a:p>
@@ -1239,7 +1240,7 @@
           <a:p>
             <a:fld id="{65ED2174-11EF-43AA-A635-42A92FC4881C}" type="datetimeFigureOut">
               <a:rPr lang="en-US" smtClean="0"/>
-              <a:t>5/12/2026</a:t>
+              <a:t>5/15/2026</a:t>
             </a:fld>
             <a:endParaRPr lang="en-US"/>
           </a:p>
@@ -1409,7 +1410,7 @@
           <a:p>
             <a:fld id="{65ED2174-11EF-43AA-A635-42A92FC4881C}" type="datetimeFigureOut">
               <a:rPr lang="en-US" smtClean="0"/>
-              <a:t>5/12/2026</a:t>
+              <a:t>5/15/2026</a:t>
             </a:fld>
             <a:endParaRPr lang="en-US"/>
           </a:p>
@@ -1653,7 +1654,7 @@
           <a:p>
             <a:fld id="{65ED2174-11EF-43AA-A635-42A92FC4881C}" type="datetimeFigureOut">
               <a:rPr lang="en-US" smtClean="0"/>
-              <a:t>5/12/2026</a:t>
+              <a:t>5/15/2026</a:t>
             </a:fld>
             <a:endParaRPr lang="en-US"/>
           </a:p>
@@ -1885,7 +1886,7 @@
           <a:p>
             <a:fld id="{65ED2174-11EF-43AA-A635-42A92FC4881C}" type="datetimeFigureOut">
               <a:rPr lang="en-US" smtClean="0"/>
-              <a:t>5/12/2026</a:t>
+              <a:t>5/15/2026</a:t>
             </a:fld>
             <a:endParaRPr lang="en-US"/>
           </a:p>
@@ -2252,7 +2253,7 @@
           <a:p>
             <a:fld id="{65ED2174-11EF-43AA-A635-42A92FC4881C}" type="datetimeFigureOut">
               <a:rPr lang="en-US" smtClean="0"/>
-              <a:t>5/12/2026</a:t>
+              <a:t>5/15/2026</a:t>
             </a:fld>
             <a:endParaRPr lang="en-US"/>
           </a:p>
@@ -2370,7 +2371,7 @@
           <a:p>
             <a:fld id="{65ED2174-11EF-43AA-A635-42A92FC4881C}" type="datetimeFigureOut">
               <a:rPr lang="en-US" smtClean="0"/>
-              <a:t>5/12/2026</a:t>
+              <a:t>5/15/2026</a:t>
             </a:fld>
             <a:endParaRPr lang="en-US"/>
           </a:p>
@@ -2465,7 +2466,7 @@
           <a:p>
             <a:fld id="{65ED2174-11EF-43AA-A635-42A92FC4881C}" type="datetimeFigureOut">
               <a:rPr lang="en-US" smtClean="0"/>
-              <a:t>5/12/2026</a:t>
+              <a:t>5/15/2026</a:t>
             </a:fld>
             <a:endParaRPr lang="en-US"/>
           </a:p>
@@ -2742,7 +2743,7 @@
           <a:p>
             <a:fld id="{65ED2174-11EF-43AA-A635-42A92FC4881C}" type="datetimeFigureOut">
               <a:rPr lang="en-US" smtClean="0"/>
-              <a:t>5/12/2026</a:t>
+              <a:t>5/15/2026</a:t>
             </a:fld>
             <a:endParaRPr lang="en-US"/>
           </a:p>
@@ -2999,7 +3000,7 @@
           <a:p>
             <a:fld id="{65ED2174-11EF-43AA-A635-42A92FC4881C}" type="datetimeFigureOut">
               <a:rPr lang="en-US" smtClean="0"/>
-              <a:t>5/12/2026</a:t>
+              <a:t>5/15/2026</a:t>
             </a:fld>
             <a:endParaRPr lang="en-US"/>
           </a:p>
@@ -3212,7 +3213,7 @@
           <a:p>
             <a:fld id="{65ED2174-11EF-43AA-A635-42A92FC4881C}" type="datetimeFigureOut">
               <a:rPr lang="en-US" smtClean="0"/>
-              <a:t>5/12/2026</a:t>
+              <a:t>5/15/2026</a:t>
             </a:fld>
             <a:endParaRPr lang="en-US"/>
           </a:p>
@@ -4039,6 +4040,237 @@
 </file>
 
 <file path=ppt/slides/slide10.xml><?xml version="1.0" encoding="utf-8"?>
+<p:sld xmlns:a="http://schemas.openxmlformats.org/drawingml/2006/main" xmlns:r="http://schemas.openxmlformats.org/officeDocument/2006/relationships" xmlns:p="http://schemas.openxmlformats.org/presentationml/2006/main">
+  <p:cSld>
+    <p:spTree>
+      <p:nvGrpSpPr>
+        <p:cNvPr id="1" name=""/>
+        <p:cNvGrpSpPr/>
+        <p:nvPr/>
+      </p:nvGrpSpPr>
+      <p:grpSpPr>
+        <a:xfrm>
+          <a:off x="0" y="0"/>
+          <a:ext cx="0" cy="0"/>
+          <a:chOff x="0" y="0"/>
+          <a:chExt cx="0" cy="0"/>
+        </a:xfrm>
+      </p:grpSpPr>
+      <p:pic>
+        <p:nvPicPr>
+          <p:cNvPr id="7" name="Picture 6"/>
+          <p:cNvPicPr>
+            <a:picLocks noChangeAspect="1"/>
+          </p:cNvPicPr>
+          <p:nvPr/>
+        </p:nvPicPr>
+        <p:blipFill>
+          <a:blip r:embed="rId2"/>
+          <a:stretch>
+            <a:fillRect/>
+          </a:stretch>
+        </p:blipFill>
+        <p:spPr>
+          <a:xfrm>
+            <a:off x="730154" y="4447500"/>
+            <a:ext cx="5846045" cy="4389120"/>
+          </a:xfrm>
+          <a:prstGeom prst="rect">
+            <a:avLst/>
+          </a:prstGeom>
+        </p:spPr>
+      </p:pic>
+      <p:pic>
+        <p:nvPicPr>
+          <p:cNvPr id="8" name="Picture 7"/>
+          <p:cNvPicPr>
+            <a:picLocks noChangeAspect="1"/>
+          </p:cNvPicPr>
+          <p:nvPr/>
+        </p:nvPicPr>
+        <p:blipFill>
+          <a:blip r:embed="rId3"/>
+          <a:stretch>
+            <a:fillRect/>
+          </a:stretch>
+        </p:blipFill>
+        <p:spPr>
+          <a:xfrm>
+            <a:off x="6032408" y="4447500"/>
+            <a:ext cx="5846045" cy="4389120"/>
+          </a:xfrm>
+          <a:prstGeom prst="rect">
+            <a:avLst/>
+          </a:prstGeom>
+        </p:spPr>
+      </p:pic>
+      <p:pic>
+        <p:nvPicPr>
+          <p:cNvPr id="9" name="Picture 8"/>
+          <p:cNvPicPr>
+            <a:picLocks noChangeAspect="1"/>
+          </p:cNvPicPr>
+          <p:nvPr/>
+        </p:nvPicPr>
+        <p:blipFill>
+          <a:blip r:embed="rId4"/>
+          <a:stretch>
+            <a:fillRect/>
+          </a:stretch>
+        </p:blipFill>
+        <p:spPr>
+          <a:xfrm>
+            <a:off x="11334660" y="4447500"/>
+            <a:ext cx="5846045" cy="4389120"/>
+          </a:xfrm>
+          <a:prstGeom prst="rect">
+            <a:avLst/>
+          </a:prstGeom>
+        </p:spPr>
+      </p:pic>
+      <p:sp>
+        <p:nvSpPr>
+          <p:cNvPr id="2" name="TextBox 1">
+            <a:extLst>
+              <a:ext uri="{FF2B5EF4-FFF2-40B4-BE49-F238E27FC236}">
+                <a16:creationId xmlns:a16="http://schemas.microsoft.com/office/drawing/2014/main" id="{CEAE48B9-7DD6-AF4F-64F3-CD6D8C6A0689}"/>
+              </a:ext>
+            </a:extLst>
+          </p:cNvPr>
+          <p:cNvSpPr txBox="1"/>
+          <p:nvPr/>
+        </p:nvSpPr>
+        <p:spPr>
+          <a:xfrm>
+            <a:off x="1406851" y="4869860"/>
+            <a:ext cx="628651" cy="400110"/>
+          </a:xfrm>
+          <a:prstGeom prst="rect">
+            <a:avLst/>
+          </a:prstGeom>
+          <a:noFill/>
+        </p:spPr>
+        <p:txBody>
+          <a:bodyPr wrap="square" rtlCol="0">
+            <a:spAutoFit/>
+          </a:bodyPr>
+          <a:lstStyle/>
+          <a:p>
+            <a:pPr algn="ctr"/>
+            <a:r>
+              <a:rPr lang="en-US" sz="2000" b="1" dirty="0">
+                <a:latin typeface="Arial" panose="020B0604020202020204" pitchFamily="34" charset="0"/>
+                <a:cs typeface="Arial" panose="020B0604020202020204" pitchFamily="34" charset="0"/>
+              </a:rPr>
+              <a:t>(a)</a:t>
+            </a:r>
+            <a:endParaRPr lang="en-GB" sz="2000" b="1" dirty="0">
+              <a:latin typeface="Arial" panose="020B0604020202020204" pitchFamily="34" charset="0"/>
+              <a:cs typeface="Arial" panose="020B0604020202020204" pitchFamily="34" charset="0"/>
+            </a:endParaRPr>
+          </a:p>
+        </p:txBody>
+      </p:sp>
+      <p:sp>
+        <p:nvSpPr>
+          <p:cNvPr id="3" name="TextBox 2">
+            <a:extLst>
+              <a:ext uri="{FF2B5EF4-FFF2-40B4-BE49-F238E27FC236}">
+                <a16:creationId xmlns:a16="http://schemas.microsoft.com/office/drawing/2014/main" id="{D2C50EB3-F724-F5FE-A4F0-4DE179F8D923}"/>
+              </a:ext>
+            </a:extLst>
+          </p:cNvPr>
+          <p:cNvSpPr txBox="1"/>
+          <p:nvPr/>
+        </p:nvSpPr>
+        <p:spPr>
+          <a:xfrm>
+            <a:off x="6713011" y="4869860"/>
+            <a:ext cx="628651" cy="400110"/>
+          </a:xfrm>
+          <a:prstGeom prst="rect">
+            <a:avLst/>
+          </a:prstGeom>
+          <a:noFill/>
+        </p:spPr>
+        <p:txBody>
+          <a:bodyPr wrap="square" rtlCol="0">
+            <a:spAutoFit/>
+          </a:bodyPr>
+          <a:lstStyle/>
+          <a:p>
+            <a:pPr algn="ctr"/>
+            <a:r>
+              <a:rPr lang="en-US" sz="2000" b="1" dirty="0">
+                <a:latin typeface="Arial" panose="020B0604020202020204" pitchFamily="34" charset="0"/>
+                <a:cs typeface="Arial" panose="020B0604020202020204" pitchFamily="34" charset="0"/>
+              </a:rPr>
+              <a:t>(b)</a:t>
+            </a:r>
+            <a:endParaRPr lang="en-GB" sz="2000" b="1" dirty="0">
+              <a:latin typeface="Arial" panose="020B0604020202020204" pitchFamily="34" charset="0"/>
+              <a:cs typeface="Arial" panose="020B0604020202020204" pitchFamily="34" charset="0"/>
+            </a:endParaRPr>
+          </a:p>
+        </p:txBody>
+      </p:sp>
+      <p:sp>
+        <p:nvSpPr>
+          <p:cNvPr id="4" name="TextBox 3">
+            <a:extLst>
+              <a:ext uri="{FF2B5EF4-FFF2-40B4-BE49-F238E27FC236}">
+                <a16:creationId xmlns:a16="http://schemas.microsoft.com/office/drawing/2014/main" id="{43FBA634-5D03-0A0E-4998-DB3D37132AEF}"/>
+              </a:ext>
+            </a:extLst>
+          </p:cNvPr>
+          <p:cNvSpPr txBox="1"/>
+          <p:nvPr/>
+        </p:nvSpPr>
+        <p:spPr>
+          <a:xfrm>
+            <a:off x="12019174" y="4869860"/>
+            <a:ext cx="628651" cy="400110"/>
+          </a:xfrm>
+          <a:prstGeom prst="rect">
+            <a:avLst/>
+          </a:prstGeom>
+          <a:noFill/>
+        </p:spPr>
+        <p:txBody>
+          <a:bodyPr wrap="square" rtlCol="0">
+            <a:spAutoFit/>
+          </a:bodyPr>
+          <a:lstStyle/>
+          <a:p>
+            <a:pPr algn="ctr"/>
+            <a:r>
+              <a:rPr lang="en-US" sz="2000" b="1" dirty="0">
+                <a:latin typeface="Arial" panose="020B0604020202020204" pitchFamily="34" charset="0"/>
+                <a:cs typeface="Arial" panose="020B0604020202020204" pitchFamily="34" charset="0"/>
+              </a:rPr>
+              <a:t>(c)</a:t>
+            </a:r>
+            <a:endParaRPr lang="en-GB" sz="2000" b="1" dirty="0">
+              <a:latin typeface="Arial" panose="020B0604020202020204" pitchFamily="34" charset="0"/>
+              <a:cs typeface="Arial" panose="020B0604020202020204" pitchFamily="34" charset="0"/>
+            </a:endParaRPr>
+          </a:p>
+        </p:txBody>
+      </p:sp>
+    </p:spTree>
+    <p:extLst>
+      <p:ext uri="{BB962C8B-B14F-4D97-AF65-F5344CB8AC3E}">
+        <p14:creationId xmlns:p14="http://schemas.microsoft.com/office/powerpoint/2010/main" val="454069972"/>
+      </p:ext>
+    </p:extLst>
+  </p:cSld>
+  <p:clrMapOvr>
+    <a:masterClrMapping/>
+  </p:clrMapOvr>
+</p:sld>
+</file>
+
+<file path=ppt/slides/slide11.xml><?xml version="1.0" encoding="utf-8"?>
 <p:sld xmlns:a="http://schemas.openxmlformats.org/drawingml/2006/main" xmlns:r="http://schemas.openxmlformats.org/officeDocument/2006/relationships" xmlns:p="http://schemas.openxmlformats.org/presentationml/2006/main">
   <p:cSld>
     <p:spTree>
@@ -27211,7 +27443,13 @@
   <p:cSld>
     <p:spTree>
       <p:nvGrpSpPr>
-        <p:cNvPr id="1" name=""/>
+        <p:cNvPr id="1" name="">
+          <a:extLst>
+            <a:ext uri="{FF2B5EF4-FFF2-40B4-BE49-F238E27FC236}">
+              <a16:creationId xmlns:a16="http://schemas.microsoft.com/office/drawing/2014/main" id="{0AF37F38-AC53-2511-5834-FCB20DB15E2B}"/>
+            </a:ext>
+          </a:extLst>
+        </p:cNvPr>
         <p:cNvGrpSpPr/>
         <p:nvPr/>
       </p:nvGrpSpPr>
@@ -27225,7 +27463,13 @@
       </p:grpSpPr>
       <p:pic>
         <p:nvPicPr>
-          <p:cNvPr id="7" name="Picture 6"/>
+          <p:cNvPr id="55" name="Picture 54">
+            <a:extLst>
+              <a:ext uri="{FF2B5EF4-FFF2-40B4-BE49-F238E27FC236}">
+                <a16:creationId xmlns:a16="http://schemas.microsoft.com/office/drawing/2014/main" id="{EE79C004-6CF8-1306-895D-B6DA7E7EF074}"/>
+              </a:ext>
+            </a:extLst>
+          </p:cNvPr>
           <p:cNvPicPr>
             <a:picLocks noChangeAspect="1"/>
           </p:cNvPicPr>
@@ -27239,195 +27483,610 @@
         </p:blipFill>
         <p:spPr>
           <a:xfrm>
-            <a:off x="730154" y="4447500"/>
-            <a:ext cx="5846045" cy="4389120"/>
+            <a:off x="1753371" y="986443"/>
+            <a:ext cx="12953250" cy="9725099"/>
           </a:xfrm>
           <a:prstGeom prst="rect">
             <a:avLst/>
           </a:prstGeom>
         </p:spPr>
       </p:pic>
-      <p:pic>
-        <p:nvPicPr>
-          <p:cNvPr id="8" name="Picture 7"/>
-          <p:cNvPicPr>
-            <a:picLocks noChangeAspect="1"/>
-          </p:cNvPicPr>
-          <p:nvPr/>
-        </p:nvPicPr>
-        <p:blipFill>
-          <a:blip r:embed="rId3"/>
-          <a:stretch>
-            <a:fillRect/>
-          </a:stretch>
-        </p:blipFill>
-        <p:spPr>
-          <a:xfrm>
-            <a:off x="6032408" y="4447500"/>
-            <a:ext cx="5846045" cy="4389120"/>
-          </a:xfrm>
-          <a:prstGeom prst="rect">
-            <a:avLst/>
-          </a:prstGeom>
-        </p:spPr>
-      </p:pic>
-      <p:pic>
-        <p:nvPicPr>
-          <p:cNvPr id="9" name="Picture 8"/>
-          <p:cNvPicPr>
-            <a:picLocks noChangeAspect="1"/>
-          </p:cNvPicPr>
-          <p:nvPr/>
-        </p:nvPicPr>
-        <p:blipFill>
-          <a:blip r:embed="rId4"/>
-          <a:stretch>
-            <a:fillRect/>
-          </a:stretch>
-        </p:blipFill>
-        <p:spPr>
-          <a:xfrm>
-            <a:off x="11334660" y="4447500"/>
-            <a:ext cx="5846045" cy="4389120"/>
-          </a:xfrm>
-          <a:prstGeom prst="rect">
-            <a:avLst/>
-          </a:prstGeom>
-        </p:spPr>
-      </p:pic>
-      <p:sp>
-        <p:nvSpPr>
-          <p:cNvPr id="2" name="TextBox 1">
-            <a:extLst>
-              <a:ext uri="{FF2B5EF4-FFF2-40B4-BE49-F238E27FC236}">
-                <a16:creationId xmlns:a16="http://schemas.microsoft.com/office/drawing/2014/main" id="{CEAE48B9-7DD6-AF4F-64F3-CD6D8C6A0689}"/>
-              </a:ext>
-            </a:extLst>
-          </p:cNvPr>
-          <p:cNvSpPr txBox="1"/>
-          <p:nvPr/>
-        </p:nvSpPr>
-        <p:spPr>
-          <a:xfrm>
-            <a:off x="1406851" y="4869860"/>
-            <a:ext cx="628651" cy="400110"/>
-          </a:xfrm>
-          <a:prstGeom prst="rect">
-            <a:avLst/>
-          </a:prstGeom>
-          <a:noFill/>
-        </p:spPr>
-        <p:txBody>
-          <a:bodyPr wrap="square" rtlCol="0">
-            <a:spAutoFit/>
-          </a:bodyPr>
-          <a:lstStyle/>
-          <a:p>
-            <a:pPr algn="ctr"/>
-            <a:r>
-              <a:rPr lang="en-US" sz="2000" b="1" dirty="0">
-                <a:latin typeface="Arial" panose="020B0604020202020204" pitchFamily="34" charset="0"/>
-                <a:cs typeface="Arial" panose="020B0604020202020204" pitchFamily="34" charset="0"/>
-              </a:rPr>
-              <a:t>(a)</a:t>
-            </a:r>
-            <a:endParaRPr lang="en-GB" sz="2000" b="1" dirty="0">
-              <a:latin typeface="Arial" panose="020B0604020202020204" pitchFamily="34" charset="0"/>
-              <a:cs typeface="Arial" panose="020B0604020202020204" pitchFamily="34" charset="0"/>
-            </a:endParaRPr>
-          </a:p>
-        </p:txBody>
-      </p:sp>
-      <p:sp>
-        <p:nvSpPr>
-          <p:cNvPr id="3" name="TextBox 2">
-            <a:extLst>
-              <a:ext uri="{FF2B5EF4-FFF2-40B4-BE49-F238E27FC236}">
-                <a16:creationId xmlns:a16="http://schemas.microsoft.com/office/drawing/2014/main" id="{D2C50EB3-F724-F5FE-A4F0-4DE179F8D923}"/>
-              </a:ext>
-            </a:extLst>
-          </p:cNvPr>
-          <p:cNvSpPr txBox="1"/>
-          <p:nvPr/>
-        </p:nvSpPr>
-        <p:spPr>
-          <a:xfrm>
-            <a:off x="6713011" y="4869860"/>
-            <a:ext cx="628651" cy="400110"/>
-          </a:xfrm>
-          <a:prstGeom prst="rect">
-            <a:avLst/>
-          </a:prstGeom>
-          <a:noFill/>
-        </p:spPr>
-        <p:txBody>
-          <a:bodyPr wrap="square" rtlCol="0">
-            <a:spAutoFit/>
-          </a:bodyPr>
-          <a:lstStyle/>
-          <a:p>
-            <a:pPr algn="ctr"/>
-            <a:r>
-              <a:rPr lang="en-US" sz="2000" b="1" dirty="0">
-                <a:latin typeface="Arial" panose="020B0604020202020204" pitchFamily="34" charset="0"/>
-                <a:cs typeface="Arial" panose="020B0604020202020204" pitchFamily="34" charset="0"/>
-              </a:rPr>
-              <a:t>(b)</a:t>
-            </a:r>
-            <a:endParaRPr lang="en-GB" sz="2000" b="1" dirty="0">
-              <a:latin typeface="Arial" panose="020B0604020202020204" pitchFamily="34" charset="0"/>
-              <a:cs typeface="Arial" panose="020B0604020202020204" pitchFamily="34" charset="0"/>
-            </a:endParaRPr>
-          </a:p>
-        </p:txBody>
-      </p:sp>
-      <p:sp>
-        <p:nvSpPr>
-          <p:cNvPr id="4" name="TextBox 3">
-            <a:extLst>
-              <a:ext uri="{FF2B5EF4-FFF2-40B4-BE49-F238E27FC236}">
-                <a16:creationId xmlns:a16="http://schemas.microsoft.com/office/drawing/2014/main" id="{43FBA634-5D03-0A0E-4998-DB3D37132AEF}"/>
-              </a:ext>
-            </a:extLst>
-          </p:cNvPr>
-          <p:cNvSpPr txBox="1"/>
-          <p:nvPr/>
-        </p:nvSpPr>
-        <p:spPr>
-          <a:xfrm>
-            <a:off x="12019174" y="4869860"/>
-            <a:ext cx="628651" cy="400110"/>
-          </a:xfrm>
-          <a:prstGeom prst="rect">
-            <a:avLst/>
-          </a:prstGeom>
-          <a:noFill/>
-        </p:spPr>
-        <p:txBody>
-          <a:bodyPr wrap="square" rtlCol="0">
-            <a:spAutoFit/>
-          </a:bodyPr>
-          <a:lstStyle/>
-          <a:p>
-            <a:pPr algn="ctr"/>
-            <a:r>
-              <a:rPr lang="en-US" sz="2000" b="1" dirty="0">
-                <a:latin typeface="Arial" panose="020B0604020202020204" pitchFamily="34" charset="0"/>
-                <a:cs typeface="Arial" panose="020B0604020202020204" pitchFamily="34" charset="0"/>
-              </a:rPr>
-              <a:t>(c)</a:t>
-            </a:r>
-            <a:endParaRPr lang="en-GB" sz="2000" b="1" dirty="0">
-              <a:latin typeface="Arial" panose="020B0604020202020204" pitchFamily="34" charset="0"/>
-              <a:cs typeface="Arial" panose="020B0604020202020204" pitchFamily="34" charset="0"/>
-            </a:endParaRPr>
-          </a:p>
-        </p:txBody>
-      </p:sp>
+      <p:cxnSp>
+        <p:nvCxnSpPr>
+          <p:cNvPr id="26" name="Straight Connector 25">
+            <a:extLst>
+              <a:ext uri="{FF2B5EF4-FFF2-40B4-BE49-F238E27FC236}">
+                <a16:creationId xmlns:a16="http://schemas.microsoft.com/office/drawing/2014/main" id="{CFDF5EC9-8CA9-77FC-5DB1-6E2EE2AE3D00}"/>
+              </a:ext>
+            </a:extLst>
+          </p:cNvPr>
+          <p:cNvCxnSpPr/>
+          <p:nvPr/>
+        </p:nvCxnSpPr>
+        <p:spPr>
+          <a:xfrm>
+            <a:off x="3452326" y="2015412"/>
+            <a:ext cx="0" cy="7352523"/>
+          </a:xfrm>
+          <a:prstGeom prst="line">
+            <a:avLst/>
+          </a:prstGeom>
+          <a:ln w="28575"/>
+        </p:spPr>
+        <p:style>
+          <a:lnRef idx="1">
+            <a:schemeClr val="dk1"/>
+          </a:lnRef>
+          <a:fillRef idx="0">
+            <a:schemeClr val="dk1"/>
+          </a:fillRef>
+          <a:effectRef idx="0">
+            <a:schemeClr val="dk1"/>
+          </a:effectRef>
+          <a:fontRef idx="minor">
+            <a:schemeClr val="tx1"/>
+          </a:fontRef>
+        </p:style>
+      </p:cxnSp>
+      <p:cxnSp>
+        <p:nvCxnSpPr>
+          <p:cNvPr id="49" name="Straight Connector 48">
+            <a:extLst>
+              <a:ext uri="{FF2B5EF4-FFF2-40B4-BE49-F238E27FC236}">
+                <a16:creationId xmlns:a16="http://schemas.microsoft.com/office/drawing/2014/main" id="{B6AB8044-9711-82A7-9D89-BE36B5896370}"/>
+              </a:ext>
+            </a:extLst>
+          </p:cNvPr>
+          <p:cNvCxnSpPr/>
+          <p:nvPr/>
+        </p:nvCxnSpPr>
+        <p:spPr>
+          <a:xfrm>
+            <a:off x="4104378" y="2015412"/>
+            <a:ext cx="0" cy="7352523"/>
+          </a:xfrm>
+          <a:prstGeom prst="line">
+            <a:avLst/>
+          </a:prstGeom>
+          <a:ln w="28575"/>
+        </p:spPr>
+        <p:style>
+          <a:lnRef idx="1">
+            <a:schemeClr val="dk1"/>
+          </a:lnRef>
+          <a:fillRef idx="0">
+            <a:schemeClr val="dk1"/>
+          </a:fillRef>
+          <a:effectRef idx="0">
+            <a:schemeClr val="dk1"/>
+          </a:effectRef>
+          <a:fontRef idx="minor">
+            <a:schemeClr val="tx1"/>
+          </a:fontRef>
+        </p:style>
+      </p:cxnSp>
+      <p:cxnSp>
+        <p:nvCxnSpPr>
+          <p:cNvPr id="50" name="Straight Connector 49">
+            <a:extLst>
+              <a:ext uri="{FF2B5EF4-FFF2-40B4-BE49-F238E27FC236}">
+                <a16:creationId xmlns:a16="http://schemas.microsoft.com/office/drawing/2014/main" id="{AAECD1F1-33B2-3DD1-33AE-1EFE0C0F0A43}"/>
+              </a:ext>
+            </a:extLst>
+          </p:cNvPr>
+          <p:cNvCxnSpPr/>
+          <p:nvPr/>
+        </p:nvCxnSpPr>
+        <p:spPr>
+          <a:xfrm>
+            <a:off x="4756430" y="2015412"/>
+            <a:ext cx="0" cy="7352523"/>
+          </a:xfrm>
+          <a:prstGeom prst="line">
+            <a:avLst/>
+          </a:prstGeom>
+          <a:ln w="28575"/>
+        </p:spPr>
+        <p:style>
+          <a:lnRef idx="1">
+            <a:schemeClr val="dk1"/>
+          </a:lnRef>
+          <a:fillRef idx="0">
+            <a:schemeClr val="dk1"/>
+          </a:fillRef>
+          <a:effectRef idx="0">
+            <a:schemeClr val="dk1"/>
+          </a:effectRef>
+          <a:fontRef idx="minor">
+            <a:schemeClr val="tx1"/>
+          </a:fontRef>
+        </p:style>
+      </p:cxnSp>
+      <p:cxnSp>
+        <p:nvCxnSpPr>
+          <p:cNvPr id="51" name="Straight Connector 50">
+            <a:extLst>
+              <a:ext uri="{FF2B5EF4-FFF2-40B4-BE49-F238E27FC236}">
+                <a16:creationId xmlns:a16="http://schemas.microsoft.com/office/drawing/2014/main" id="{EFF9D86D-E75D-8D23-EDE5-F129054C6748}"/>
+              </a:ext>
+            </a:extLst>
+          </p:cNvPr>
+          <p:cNvCxnSpPr/>
+          <p:nvPr/>
+        </p:nvCxnSpPr>
+        <p:spPr>
+          <a:xfrm>
+            <a:off x="5408482" y="2015412"/>
+            <a:ext cx="0" cy="7352523"/>
+          </a:xfrm>
+          <a:prstGeom prst="line">
+            <a:avLst/>
+          </a:prstGeom>
+          <a:ln w="28575"/>
+        </p:spPr>
+        <p:style>
+          <a:lnRef idx="1">
+            <a:schemeClr val="dk1"/>
+          </a:lnRef>
+          <a:fillRef idx="0">
+            <a:schemeClr val="dk1"/>
+          </a:fillRef>
+          <a:effectRef idx="0">
+            <a:schemeClr val="dk1"/>
+          </a:effectRef>
+          <a:fontRef idx="minor">
+            <a:schemeClr val="tx1"/>
+          </a:fontRef>
+        </p:style>
+      </p:cxnSp>
+      <p:cxnSp>
+        <p:nvCxnSpPr>
+          <p:cNvPr id="52" name="Straight Connector 51">
+            <a:extLst>
+              <a:ext uri="{FF2B5EF4-FFF2-40B4-BE49-F238E27FC236}">
+                <a16:creationId xmlns:a16="http://schemas.microsoft.com/office/drawing/2014/main" id="{88CED366-6728-3179-1728-361452960A1E}"/>
+              </a:ext>
+            </a:extLst>
+          </p:cNvPr>
+          <p:cNvCxnSpPr/>
+          <p:nvPr/>
+        </p:nvCxnSpPr>
+        <p:spPr>
+          <a:xfrm>
+            <a:off x="6060534" y="2015412"/>
+            <a:ext cx="0" cy="7352523"/>
+          </a:xfrm>
+          <a:prstGeom prst="line">
+            <a:avLst/>
+          </a:prstGeom>
+          <a:ln w="28575"/>
+        </p:spPr>
+        <p:style>
+          <a:lnRef idx="1">
+            <a:schemeClr val="dk1"/>
+          </a:lnRef>
+          <a:fillRef idx="0">
+            <a:schemeClr val="dk1"/>
+          </a:fillRef>
+          <a:effectRef idx="0">
+            <a:schemeClr val="dk1"/>
+          </a:effectRef>
+          <a:fontRef idx="minor">
+            <a:schemeClr val="tx1"/>
+          </a:fontRef>
+        </p:style>
+      </p:cxnSp>
+      <p:cxnSp>
+        <p:nvCxnSpPr>
+          <p:cNvPr id="53" name="Straight Connector 52">
+            <a:extLst>
+              <a:ext uri="{FF2B5EF4-FFF2-40B4-BE49-F238E27FC236}">
+                <a16:creationId xmlns:a16="http://schemas.microsoft.com/office/drawing/2014/main" id="{F9247B99-948F-9B5C-CD6C-33133F273822}"/>
+              </a:ext>
+            </a:extLst>
+          </p:cNvPr>
+          <p:cNvCxnSpPr/>
+          <p:nvPr/>
+        </p:nvCxnSpPr>
+        <p:spPr>
+          <a:xfrm>
+            <a:off x="6712586" y="2015412"/>
+            <a:ext cx="0" cy="7352523"/>
+          </a:xfrm>
+          <a:prstGeom prst="line">
+            <a:avLst/>
+          </a:prstGeom>
+          <a:ln w="28575"/>
+        </p:spPr>
+        <p:style>
+          <a:lnRef idx="1">
+            <a:schemeClr val="dk1"/>
+          </a:lnRef>
+          <a:fillRef idx="0">
+            <a:schemeClr val="dk1"/>
+          </a:fillRef>
+          <a:effectRef idx="0">
+            <a:schemeClr val="dk1"/>
+          </a:effectRef>
+          <a:fontRef idx="minor">
+            <a:schemeClr val="tx1"/>
+          </a:fontRef>
+        </p:style>
+      </p:cxnSp>
+      <p:cxnSp>
+        <p:nvCxnSpPr>
+          <p:cNvPr id="54" name="Straight Connector 53">
+            <a:extLst>
+              <a:ext uri="{FF2B5EF4-FFF2-40B4-BE49-F238E27FC236}">
+                <a16:creationId xmlns:a16="http://schemas.microsoft.com/office/drawing/2014/main" id="{64B653C0-DD4C-2AFB-84C7-6A2003F7DDEB}"/>
+              </a:ext>
+            </a:extLst>
+          </p:cNvPr>
+          <p:cNvCxnSpPr/>
+          <p:nvPr/>
+        </p:nvCxnSpPr>
+        <p:spPr>
+          <a:xfrm>
+            <a:off x="7364638" y="2015412"/>
+            <a:ext cx="0" cy="7352523"/>
+          </a:xfrm>
+          <a:prstGeom prst="line">
+            <a:avLst/>
+          </a:prstGeom>
+          <a:ln w="28575"/>
+        </p:spPr>
+        <p:style>
+          <a:lnRef idx="1">
+            <a:schemeClr val="dk1"/>
+          </a:lnRef>
+          <a:fillRef idx="0">
+            <a:schemeClr val="dk1"/>
+          </a:fillRef>
+          <a:effectRef idx="0">
+            <a:schemeClr val="dk1"/>
+          </a:effectRef>
+          <a:fontRef idx="minor">
+            <a:schemeClr val="tx1"/>
+          </a:fontRef>
+        </p:style>
+      </p:cxnSp>
+      <p:cxnSp>
+        <p:nvCxnSpPr>
+          <p:cNvPr id="56" name="Straight Connector 55">
+            <a:extLst>
+              <a:ext uri="{FF2B5EF4-FFF2-40B4-BE49-F238E27FC236}">
+                <a16:creationId xmlns:a16="http://schemas.microsoft.com/office/drawing/2014/main" id="{9747DB38-6975-752E-8A38-81785150E184}"/>
+              </a:ext>
+            </a:extLst>
+          </p:cNvPr>
+          <p:cNvCxnSpPr/>
+          <p:nvPr/>
+        </p:nvCxnSpPr>
+        <p:spPr>
+          <a:xfrm>
+            <a:off x="8016690" y="2015412"/>
+            <a:ext cx="0" cy="7352523"/>
+          </a:xfrm>
+          <a:prstGeom prst="line">
+            <a:avLst/>
+          </a:prstGeom>
+          <a:ln w="28575"/>
+        </p:spPr>
+        <p:style>
+          <a:lnRef idx="1">
+            <a:schemeClr val="dk1"/>
+          </a:lnRef>
+          <a:fillRef idx="0">
+            <a:schemeClr val="dk1"/>
+          </a:fillRef>
+          <a:effectRef idx="0">
+            <a:schemeClr val="dk1"/>
+          </a:effectRef>
+          <a:fontRef idx="minor">
+            <a:schemeClr val="tx1"/>
+          </a:fontRef>
+        </p:style>
+      </p:cxnSp>
+      <p:cxnSp>
+        <p:nvCxnSpPr>
+          <p:cNvPr id="61" name="Straight Connector 60">
+            <a:extLst>
+              <a:ext uri="{FF2B5EF4-FFF2-40B4-BE49-F238E27FC236}">
+                <a16:creationId xmlns:a16="http://schemas.microsoft.com/office/drawing/2014/main" id="{DD2BCA79-459E-1731-4CEE-4607D72E066E}"/>
+              </a:ext>
+            </a:extLst>
+          </p:cNvPr>
+          <p:cNvCxnSpPr/>
+          <p:nvPr/>
+        </p:nvCxnSpPr>
+        <p:spPr>
+          <a:xfrm>
+            <a:off x="8668742" y="2015412"/>
+            <a:ext cx="0" cy="7352523"/>
+          </a:xfrm>
+          <a:prstGeom prst="line">
+            <a:avLst/>
+          </a:prstGeom>
+          <a:ln w="28575"/>
+        </p:spPr>
+        <p:style>
+          <a:lnRef idx="1">
+            <a:schemeClr val="dk1"/>
+          </a:lnRef>
+          <a:fillRef idx="0">
+            <a:schemeClr val="dk1"/>
+          </a:fillRef>
+          <a:effectRef idx="0">
+            <a:schemeClr val="dk1"/>
+          </a:effectRef>
+          <a:fontRef idx="minor">
+            <a:schemeClr val="tx1"/>
+          </a:fontRef>
+        </p:style>
+      </p:cxnSp>
+      <p:cxnSp>
+        <p:nvCxnSpPr>
+          <p:cNvPr id="62" name="Straight Connector 61">
+            <a:extLst>
+              <a:ext uri="{FF2B5EF4-FFF2-40B4-BE49-F238E27FC236}">
+                <a16:creationId xmlns:a16="http://schemas.microsoft.com/office/drawing/2014/main" id="{96417B30-15BC-18C2-425A-710DA93933CC}"/>
+              </a:ext>
+            </a:extLst>
+          </p:cNvPr>
+          <p:cNvCxnSpPr/>
+          <p:nvPr/>
+        </p:nvCxnSpPr>
+        <p:spPr>
+          <a:xfrm>
+            <a:off x="9320794" y="2015412"/>
+            <a:ext cx="0" cy="7352523"/>
+          </a:xfrm>
+          <a:prstGeom prst="line">
+            <a:avLst/>
+          </a:prstGeom>
+          <a:ln w="28575"/>
+        </p:spPr>
+        <p:style>
+          <a:lnRef idx="1">
+            <a:schemeClr val="dk1"/>
+          </a:lnRef>
+          <a:fillRef idx="0">
+            <a:schemeClr val="dk1"/>
+          </a:fillRef>
+          <a:effectRef idx="0">
+            <a:schemeClr val="dk1"/>
+          </a:effectRef>
+          <a:fontRef idx="minor">
+            <a:schemeClr val="tx1"/>
+          </a:fontRef>
+        </p:style>
+      </p:cxnSp>
+      <p:cxnSp>
+        <p:nvCxnSpPr>
+          <p:cNvPr id="63" name="Straight Connector 62">
+            <a:extLst>
+              <a:ext uri="{FF2B5EF4-FFF2-40B4-BE49-F238E27FC236}">
+                <a16:creationId xmlns:a16="http://schemas.microsoft.com/office/drawing/2014/main" id="{29793A8F-9C1E-15B2-F013-6EA6266D610F}"/>
+              </a:ext>
+            </a:extLst>
+          </p:cNvPr>
+          <p:cNvCxnSpPr/>
+          <p:nvPr/>
+        </p:nvCxnSpPr>
+        <p:spPr>
+          <a:xfrm>
+            <a:off x="9972846" y="2015412"/>
+            <a:ext cx="0" cy="7352523"/>
+          </a:xfrm>
+          <a:prstGeom prst="line">
+            <a:avLst/>
+          </a:prstGeom>
+          <a:ln w="28575"/>
+        </p:spPr>
+        <p:style>
+          <a:lnRef idx="1">
+            <a:schemeClr val="dk1"/>
+          </a:lnRef>
+          <a:fillRef idx="0">
+            <a:schemeClr val="dk1"/>
+          </a:fillRef>
+          <a:effectRef idx="0">
+            <a:schemeClr val="dk1"/>
+          </a:effectRef>
+          <a:fontRef idx="minor">
+            <a:schemeClr val="tx1"/>
+          </a:fontRef>
+        </p:style>
+      </p:cxnSp>
+      <p:cxnSp>
+        <p:nvCxnSpPr>
+          <p:cNvPr id="64" name="Straight Connector 63">
+            <a:extLst>
+              <a:ext uri="{FF2B5EF4-FFF2-40B4-BE49-F238E27FC236}">
+                <a16:creationId xmlns:a16="http://schemas.microsoft.com/office/drawing/2014/main" id="{87B557C3-6666-FDEC-2816-1F115143DF14}"/>
+              </a:ext>
+            </a:extLst>
+          </p:cNvPr>
+          <p:cNvCxnSpPr/>
+          <p:nvPr/>
+        </p:nvCxnSpPr>
+        <p:spPr>
+          <a:xfrm>
+            <a:off x="10624898" y="2015412"/>
+            <a:ext cx="0" cy="7352523"/>
+          </a:xfrm>
+          <a:prstGeom prst="line">
+            <a:avLst/>
+          </a:prstGeom>
+          <a:ln w="28575"/>
+        </p:spPr>
+        <p:style>
+          <a:lnRef idx="1">
+            <a:schemeClr val="dk1"/>
+          </a:lnRef>
+          <a:fillRef idx="0">
+            <a:schemeClr val="dk1"/>
+          </a:fillRef>
+          <a:effectRef idx="0">
+            <a:schemeClr val="dk1"/>
+          </a:effectRef>
+          <a:fontRef idx="minor">
+            <a:schemeClr val="tx1"/>
+          </a:fontRef>
+        </p:style>
+      </p:cxnSp>
+      <p:cxnSp>
+        <p:nvCxnSpPr>
+          <p:cNvPr id="65" name="Straight Connector 64">
+            <a:extLst>
+              <a:ext uri="{FF2B5EF4-FFF2-40B4-BE49-F238E27FC236}">
+                <a16:creationId xmlns:a16="http://schemas.microsoft.com/office/drawing/2014/main" id="{8374B599-5F3A-A848-BB8E-EED1A07E4CC0}"/>
+              </a:ext>
+            </a:extLst>
+          </p:cNvPr>
+          <p:cNvCxnSpPr/>
+          <p:nvPr/>
+        </p:nvCxnSpPr>
+        <p:spPr>
+          <a:xfrm>
+            <a:off x="11276950" y="2015412"/>
+            <a:ext cx="0" cy="7352523"/>
+          </a:xfrm>
+          <a:prstGeom prst="line">
+            <a:avLst/>
+          </a:prstGeom>
+          <a:ln w="28575"/>
+        </p:spPr>
+        <p:style>
+          <a:lnRef idx="1">
+            <a:schemeClr val="dk1"/>
+          </a:lnRef>
+          <a:fillRef idx="0">
+            <a:schemeClr val="dk1"/>
+          </a:fillRef>
+          <a:effectRef idx="0">
+            <a:schemeClr val="dk1"/>
+          </a:effectRef>
+          <a:fontRef idx="minor">
+            <a:schemeClr val="tx1"/>
+          </a:fontRef>
+        </p:style>
+      </p:cxnSp>
+      <p:cxnSp>
+        <p:nvCxnSpPr>
+          <p:cNvPr id="66" name="Straight Connector 65">
+            <a:extLst>
+              <a:ext uri="{FF2B5EF4-FFF2-40B4-BE49-F238E27FC236}">
+                <a16:creationId xmlns:a16="http://schemas.microsoft.com/office/drawing/2014/main" id="{D6443B4A-EF93-48AE-A7FD-0F2BB9F6DAA6}"/>
+              </a:ext>
+            </a:extLst>
+          </p:cNvPr>
+          <p:cNvCxnSpPr/>
+          <p:nvPr/>
+        </p:nvCxnSpPr>
+        <p:spPr>
+          <a:xfrm>
+            <a:off x="11929002" y="2015412"/>
+            <a:ext cx="0" cy="7352523"/>
+          </a:xfrm>
+          <a:prstGeom prst="line">
+            <a:avLst/>
+          </a:prstGeom>
+          <a:ln w="28575"/>
+        </p:spPr>
+        <p:style>
+          <a:lnRef idx="1">
+            <a:schemeClr val="dk1"/>
+          </a:lnRef>
+          <a:fillRef idx="0">
+            <a:schemeClr val="dk1"/>
+          </a:fillRef>
+          <a:effectRef idx="0">
+            <a:schemeClr val="dk1"/>
+          </a:effectRef>
+          <a:fontRef idx="minor">
+            <a:schemeClr val="tx1"/>
+          </a:fontRef>
+        </p:style>
+      </p:cxnSp>
+      <p:cxnSp>
+        <p:nvCxnSpPr>
+          <p:cNvPr id="67" name="Straight Connector 66">
+            <a:extLst>
+              <a:ext uri="{FF2B5EF4-FFF2-40B4-BE49-F238E27FC236}">
+                <a16:creationId xmlns:a16="http://schemas.microsoft.com/office/drawing/2014/main" id="{44FC8DB5-4651-18BB-54A5-007D98482CE3}"/>
+              </a:ext>
+            </a:extLst>
+          </p:cNvPr>
+          <p:cNvCxnSpPr/>
+          <p:nvPr/>
+        </p:nvCxnSpPr>
+        <p:spPr>
+          <a:xfrm>
+            <a:off x="12581054" y="2015412"/>
+            <a:ext cx="0" cy="7352523"/>
+          </a:xfrm>
+          <a:prstGeom prst="line">
+            <a:avLst/>
+          </a:prstGeom>
+          <a:ln w="28575"/>
+        </p:spPr>
+        <p:style>
+          <a:lnRef idx="1">
+            <a:schemeClr val="dk1"/>
+          </a:lnRef>
+          <a:fillRef idx="0">
+            <a:schemeClr val="dk1"/>
+          </a:fillRef>
+          <a:effectRef idx="0">
+            <a:schemeClr val="dk1"/>
+          </a:effectRef>
+          <a:fontRef idx="minor">
+            <a:schemeClr val="tx1"/>
+          </a:fontRef>
+        </p:style>
+      </p:cxnSp>
+      <p:cxnSp>
+        <p:nvCxnSpPr>
+          <p:cNvPr id="68" name="Straight Connector 67">
+            <a:extLst>
+              <a:ext uri="{FF2B5EF4-FFF2-40B4-BE49-F238E27FC236}">
+                <a16:creationId xmlns:a16="http://schemas.microsoft.com/office/drawing/2014/main" id="{60209965-83DC-CD73-DD81-F682AC7095A9}"/>
+              </a:ext>
+            </a:extLst>
+          </p:cNvPr>
+          <p:cNvCxnSpPr/>
+          <p:nvPr/>
+        </p:nvCxnSpPr>
+        <p:spPr>
+          <a:xfrm>
+            <a:off x="13233112" y="2015412"/>
+            <a:ext cx="0" cy="7352523"/>
+          </a:xfrm>
+          <a:prstGeom prst="line">
+            <a:avLst/>
+          </a:prstGeom>
+          <a:ln w="28575"/>
+        </p:spPr>
+        <p:style>
+          <a:lnRef idx="1">
+            <a:schemeClr val="dk1"/>
+          </a:lnRef>
+          <a:fillRef idx="0">
+            <a:schemeClr val="dk1"/>
+          </a:fillRef>
+          <a:effectRef idx="0">
+            <a:schemeClr val="dk1"/>
+          </a:effectRef>
+          <a:fontRef idx="minor">
+            <a:schemeClr val="tx1"/>
+          </a:fontRef>
+        </p:style>
+      </p:cxnSp>
     </p:spTree>
     <p:extLst>
       <p:ext uri="{BB962C8B-B14F-4D97-AF65-F5344CB8AC3E}">
-        <p14:creationId xmlns:p14="http://schemas.microsoft.com/office/powerpoint/2010/main" val="454069972"/>
+        <p14:creationId xmlns:p14="http://schemas.microsoft.com/office/powerpoint/2010/main" val="4263283530"/>
       </p:ext>
     </p:extLst>
   </p:cSld>

</xml_diff>